<commit_message>
Power fleet: case settings marked "Nigel / Henry to confirm"; decision D22 added
Problem
The power fleet cases rest on settings with no source. They were on the
sheet as assumptions but not assigned to anyone, and not in the decision log.

What changed
- Workbook, Power fleet sheet: 21 rows (the three assumption cells, every
  case setting, each case's results and the summary) carry "Nigel / Henry to
  confirm" in the action column.
- Decision log: D22, the three power cases and the assumptions behind them,
  unresolved, owners Nigel and Henry. The log now has 22 decisions, 10
  unresolved.
- Note: table of the eight settings to confirm, with value and basis.
- Deck: decision slide now lists ten unresolved decisions; counts are read
  from the log.

Effect on the model
None.

Checks
- python -m pytest -q: 178 passed, 1 skipped, confirmed before this commit.
- Deck exported and the decision slide inspected.

Co-Authored-By: Claude Opus 5.5 <noreply@anthropic.com>
</commit_message>
<xml_diff>
--- a/pptx/output/delivered/supporting/Vopak_Manish_Handback_2026_10_07.pptx
+++ b/pptx/output/delivered/supporting/Vopak_Manish_Handback_2026_10_07.pptx
@@ -12581,7 +12581,7 @@
                         </a:defRPr>
                       </a:pPr>
                       <a:r>
-                        <a:t>This deck, the hand-back note, a 21-item decision log, the workshop workbook with history from 2012, and 288 figures in the current pack checked with none differing</a:t>
+                        <a:t>This deck, the hand-back note, a 22-item decision log, the workshop workbook with history from 2012, and 288 figures in the current pack checked with none differing</a:t>
                       </a:r>
                     </a:p>
                   </a:txBody>
@@ -13009,7 +13009,7 @@
           <a:lstStyle/>
           <a:p>
             <a:r>
-              <a:t>Decision log: 3 ready, 9 proposed, 9 unresolved</a:t>
+              <a:t>Decision log: 3 ready, 9 proposed, 10 unresolved</a:t>
             </a:r>
           </a:p>
         </p:txBody>
@@ -13048,7 +13048,7 @@
               </a:defRPr>
             </a:pPr>
             <a:r>
-              <a:t>Decisions for Nigel | the nine that are unresolved, with the analyst's proposal | full log in the csv</a:t>
+              <a:t>Decisions for Nigel | the 10 that are unresolved, with the analyst's proposal | full log in the csv</a:t>
             </a:r>
           </a:p>
         </p:txBody>
@@ -13187,17 +13187,17 @@
                 <a:gridCol w="5257800"/>
                 <a:gridCol w="2560320"/>
               </a:tblGrid>
-              <a:tr h="429768">
-                <a:tc>
-                  <a:txBody>
-                    <a:bodyPr/>
-                    <a:lstStyle/>
-                    <a:p>
-                      <a:pPr>
-                        <a:spcAft>
-                          <a:spcPts val="100"/>
-                        </a:spcAft>
-                        <a:defRPr sz="850" b="1">
+              <a:tr h="390698">
+                <a:tc>
+                  <a:txBody>
+                    <a:bodyPr/>
+                    <a:lstStyle/>
+                    <a:p>
+                      <a:pPr>
+                        <a:spcAft>
+                          <a:spcPts val="100"/>
+                        </a:spcAft>
+                        <a:defRPr sz="800" b="1">
                           <a:solidFill>
                             <a:srgbClr val="0A2373"/>
                           </a:solidFill>
@@ -13238,7 +13238,7 @@
                         <a:spcAft>
                           <a:spcPts val="100"/>
                         </a:spcAft>
-                        <a:defRPr sz="850" b="1">
+                        <a:defRPr sz="800" b="1">
                           <a:solidFill>
                             <a:srgbClr val="11151A"/>
                           </a:solidFill>
@@ -13279,7 +13279,7 @@
                         <a:spcAft>
                           <a:spcPts val="100"/>
                         </a:spcAft>
-                        <a:defRPr sz="850" b="1">
+                        <a:defRPr sz="800" b="1">
                           <a:solidFill>
                             <a:srgbClr val="11151A"/>
                           </a:solidFill>
@@ -13312,17 +13312,17 @@
                   </a:tcPr>
                 </a:tc>
               </a:tr>
-              <a:tr h="429768">
-                <a:tc>
-                  <a:txBody>
-                    <a:bodyPr/>
-                    <a:lstStyle/>
-                    <a:p>
-                      <a:pPr>
-                        <a:spcAft>
-                          <a:spcPts val="100"/>
-                        </a:spcAft>
-                        <a:defRPr sz="850" b="1">
+              <a:tr h="390698">
+                <a:tc>
+                  <a:txBody>
+                    <a:bodyPr/>
+                    <a:lstStyle/>
+                    <a:p>
+                      <a:pPr>
+                        <a:spcAft>
+                          <a:spcPts val="100"/>
+                        </a:spcAft>
+                        <a:defRPr sz="800" b="1">
                           <a:solidFill>
                             <a:srgbClr val="0A2373"/>
                           </a:solidFill>
@@ -13363,7 +13363,7 @@
                         <a:spcAft>
                           <a:spcPts val="100"/>
                         </a:spcAft>
-                        <a:defRPr sz="850" b="0">
+                        <a:defRPr sz="800" b="0">
                           <a:solidFill>
                             <a:srgbClr val="11151A"/>
                           </a:solidFill>
@@ -13404,7 +13404,7 @@
                         <a:spcAft>
                           <a:spcPts val="100"/>
                         </a:spcAft>
-                        <a:defRPr sz="850" b="0">
+                        <a:defRPr sz="800" b="0">
                           <a:solidFill>
                             <a:srgbClr val="11151A"/>
                           </a:solidFill>
@@ -13437,17 +13437,17 @@
                   </a:tcPr>
                 </a:tc>
               </a:tr>
-              <a:tr h="429768">
-                <a:tc>
-                  <a:txBody>
-                    <a:bodyPr/>
-                    <a:lstStyle/>
-                    <a:p>
-                      <a:pPr>
-                        <a:spcAft>
-                          <a:spcPts val="100"/>
-                        </a:spcAft>
-                        <a:defRPr sz="850" b="1">
+              <a:tr h="390698">
+                <a:tc>
+                  <a:txBody>
+                    <a:bodyPr/>
+                    <a:lstStyle/>
+                    <a:p>
+                      <a:pPr>
+                        <a:spcAft>
+                          <a:spcPts val="100"/>
+                        </a:spcAft>
+                        <a:defRPr sz="800" b="1">
                           <a:solidFill>
                             <a:srgbClr val="0A2373"/>
                           </a:solidFill>
@@ -13488,7 +13488,7 @@
                         <a:spcAft>
                           <a:spcPts val="100"/>
                         </a:spcAft>
-                        <a:defRPr sz="850" b="0">
+                        <a:defRPr sz="800" b="0">
                           <a:solidFill>
                             <a:srgbClr val="11151A"/>
                           </a:solidFill>
@@ -13529,7 +13529,7 @@
                         <a:spcAft>
                           <a:spcPts val="100"/>
                         </a:spcAft>
-                        <a:defRPr sz="850" b="0">
+                        <a:defRPr sz="800" b="0">
                           <a:solidFill>
                             <a:srgbClr val="11151A"/>
                           </a:solidFill>
@@ -13562,17 +13562,17 @@
                   </a:tcPr>
                 </a:tc>
               </a:tr>
-              <a:tr h="429768">
-                <a:tc>
-                  <a:txBody>
-                    <a:bodyPr/>
-                    <a:lstStyle/>
-                    <a:p>
-                      <a:pPr>
-                        <a:spcAft>
-                          <a:spcPts val="100"/>
-                        </a:spcAft>
-                        <a:defRPr sz="850" b="1">
+              <a:tr h="390698">
+                <a:tc>
+                  <a:txBody>
+                    <a:bodyPr/>
+                    <a:lstStyle/>
+                    <a:p>
+                      <a:pPr>
+                        <a:spcAft>
+                          <a:spcPts val="100"/>
+                        </a:spcAft>
+                        <a:defRPr sz="800" b="1">
                           <a:solidFill>
                             <a:srgbClr val="0A2373"/>
                           </a:solidFill>
@@ -13613,7 +13613,7 @@
                         <a:spcAft>
                           <a:spcPts val="100"/>
                         </a:spcAft>
-                        <a:defRPr sz="850" b="0">
+                        <a:defRPr sz="800" b="0">
                           <a:solidFill>
                             <a:srgbClr val="11151A"/>
                           </a:solidFill>
@@ -13654,7 +13654,7 @@
                         <a:spcAft>
                           <a:spcPts val="100"/>
                         </a:spcAft>
-                        <a:defRPr sz="850" b="0">
+                        <a:defRPr sz="800" b="0">
                           <a:solidFill>
                             <a:srgbClr val="11151A"/>
                           </a:solidFill>
@@ -13687,17 +13687,17 @@
                   </a:tcPr>
                 </a:tc>
               </a:tr>
-              <a:tr h="429768">
-                <a:tc>
-                  <a:txBody>
-                    <a:bodyPr/>
-                    <a:lstStyle/>
-                    <a:p>
-                      <a:pPr>
-                        <a:spcAft>
-                          <a:spcPts val="100"/>
-                        </a:spcAft>
-                        <a:defRPr sz="850" b="1">
+              <a:tr h="390698">
+                <a:tc>
+                  <a:txBody>
+                    <a:bodyPr/>
+                    <a:lstStyle/>
+                    <a:p>
+                      <a:pPr>
+                        <a:spcAft>
+                          <a:spcPts val="100"/>
+                        </a:spcAft>
+                        <a:defRPr sz="800" b="1">
                           <a:solidFill>
                             <a:srgbClr val="0A2373"/>
                           </a:solidFill>
@@ -13738,7 +13738,7 @@
                         <a:spcAft>
                           <a:spcPts val="100"/>
                         </a:spcAft>
-                        <a:defRPr sz="850" b="0">
+                        <a:defRPr sz="800" b="0">
                           <a:solidFill>
                             <a:srgbClr val="11151A"/>
                           </a:solidFill>
@@ -13779,7 +13779,7 @@
                         <a:spcAft>
                           <a:spcPts val="100"/>
                         </a:spcAft>
-                        <a:defRPr sz="850" b="0">
+                        <a:defRPr sz="800" b="0">
                           <a:solidFill>
                             <a:srgbClr val="11151A"/>
                           </a:solidFill>
@@ -13812,17 +13812,17 @@
                   </a:tcPr>
                 </a:tc>
               </a:tr>
-              <a:tr h="429768">
-                <a:tc>
-                  <a:txBody>
-                    <a:bodyPr/>
-                    <a:lstStyle/>
-                    <a:p>
-                      <a:pPr>
-                        <a:spcAft>
-                          <a:spcPts val="100"/>
-                        </a:spcAft>
-                        <a:defRPr sz="850" b="1">
+              <a:tr h="390698">
+                <a:tc>
+                  <a:txBody>
+                    <a:bodyPr/>
+                    <a:lstStyle/>
+                    <a:p>
+                      <a:pPr>
+                        <a:spcAft>
+                          <a:spcPts val="100"/>
+                        </a:spcAft>
+                        <a:defRPr sz="800" b="1">
                           <a:solidFill>
                             <a:srgbClr val="0A2373"/>
                           </a:solidFill>
@@ -13863,7 +13863,7 @@
                         <a:spcAft>
                           <a:spcPts val="100"/>
                         </a:spcAft>
-                        <a:defRPr sz="850" b="0">
+                        <a:defRPr sz="800" b="0">
                           <a:solidFill>
                             <a:srgbClr val="11151A"/>
                           </a:solidFill>
@@ -13904,7 +13904,7 @@
                         <a:spcAft>
                           <a:spcPts val="100"/>
                         </a:spcAft>
-                        <a:defRPr sz="850" b="0">
+                        <a:defRPr sz="800" b="0">
                           <a:solidFill>
                             <a:srgbClr val="11151A"/>
                           </a:solidFill>
@@ -13937,17 +13937,17 @@
                   </a:tcPr>
                 </a:tc>
               </a:tr>
-              <a:tr h="429768">
-                <a:tc>
-                  <a:txBody>
-                    <a:bodyPr/>
-                    <a:lstStyle/>
-                    <a:p>
-                      <a:pPr>
-                        <a:spcAft>
-                          <a:spcPts val="100"/>
-                        </a:spcAft>
-                        <a:defRPr sz="850" b="1">
+              <a:tr h="390698">
+                <a:tc>
+                  <a:txBody>
+                    <a:bodyPr/>
+                    <a:lstStyle/>
+                    <a:p>
+                      <a:pPr>
+                        <a:spcAft>
+                          <a:spcPts val="100"/>
+                        </a:spcAft>
+                        <a:defRPr sz="800" b="1">
                           <a:solidFill>
                             <a:srgbClr val="0A2373"/>
                           </a:solidFill>
@@ -13988,7 +13988,7 @@
                         <a:spcAft>
                           <a:spcPts val="100"/>
                         </a:spcAft>
-                        <a:defRPr sz="850" b="0">
+                        <a:defRPr sz="800" b="0">
                           <a:solidFill>
                             <a:srgbClr val="11151A"/>
                           </a:solidFill>
@@ -14029,7 +14029,7 @@
                         <a:spcAft>
                           <a:spcPts val="100"/>
                         </a:spcAft>
-                        <a:defRPr sz="850" b="0">
+                        <a:defRPr sz="800" b="0">
                           <a:solidFill>
                             <a:srgbClr val="11151A"/>
                           </a:solidFill>
@@ -14062,17 +14062,17 @@
                   </a:tcPr>
                 </a:tc>
               </a:tr>
-              <a:tr h="429768">
-                <a:tc>
-                  <a:txBody>
-                    <a:bodyPr/>
-                    <a:lstStyle/>
-                    <a:p>
-                      <a:pPr>
-                        <a:spcAft>
-                          <a:spcPts val="100"/>
-                        </a:spcAft>
-                        <a:defRPr sz="850" b="1">
+              <a:tr h="390698">
+                <a:tc>
+                  <a:txBody>
+                    <a:bodyPr/>
+                    <a:lstStyle/>
+                    <a:p>
+                      <a:pPr>
+                        <a:spcAft>
+                          <a:spcPts val="100"/>
+                        </a:spcAft>
+                        <a:defRPr sz="800" b="1">
                           <a:solidFill>
                             <a:srgbClr val="0A2373"/>
                           </a:solidFill>
@@ -14113,7 +14113,7 @@
                         <a:spcAft>
                           <a:spcPts val="100"/>
                         </a:spcAft>
-                        <a:defRPr sz="850" b="0">
+                        <a:defRPr sz="800" b="0">
                           <a:solidFill>
                             <a:srgbClr val="11151A"/>
                           </a:solidFill>
@@ -14154,7 +14154,7 @@
                         <a:spcAft>
                           <a:spcPts val="100"/>
                         </a:spcAft>
-                        <a:defRPr sz="850" b="0">
+                        <a:defRPr sz="800" b="0">
                           <a:solidFill>
                             <a:srgbClr val="11151A"/>
                           </a:solidFill>
@@ -14187,17 +14187,17 @@
                   </a:tcPr>
                 </a:tc>
               </a:tr>
-              <a:tr h="429768">
-                <a:tc>
-                  <a:txBody>
-                    <a:bodyPr/>
-                    <a:lstStyle/>
-                    <a:p>
-                      <a:pPr>
-                        <a:spcAft>
-                          <a:spcPts val="100"/>
-                        </a:spcAft>
-                        <a:defRPr sz="850" b="1">
+              <a:tr h="390698">
+                <a:tc>
+                  <a:txBody>
+                    <a:bodyPr/>
+                    <a:lstStyle/>
+                    <a:p>
+                      <a:pPr>
+                        <a:spcAft>
+                          <a:spcPts val="100"/>
+                        </a:spcAft>
+                        <a:defRPr sz="800" b="1">
                           <a:solidFill>
                             <a:srgbClr val="0A2373"/>
                           </a:solidFill>
@@ -14238,7 +14238,7 @@
                         <a:spcAft>
                           <a:spcPts val="100"/>
                         </a:spcAft>
-                        <a:defRPr sz="850" b="0">
+                        <a:defRPr sz="800" b="0">
                           <a:solidFill>
                             <a:srgbClr val="11151A"/>
                           </a:solidFill>
@@ -14279,7 +14279,7 @@
                         <a:spcAft>
                           <a:spcPts val="100"/>
                         </a:spcAft>
-                        <a:defRPr sz="850" b="0">
+                        <a:defRPr sz="800" b="0">
                           <a:solidFill>
                             <a:srgbClr val="11151A"/>
                           </a:solidFill>
@@ -14312,17 +14312,17 @@
                   </a:tcPr>
                 </a:tc>
               </a:tr>
-              <a:tr h="429768">
-                <a:tc>
-                  <a:txBody>
-                    <a:bodyPr/>
-                    <a:lstStyle/>
-                    <a:p>
-                      <a:pPr>
-                        <a:spcAft>
-                          <a:spcPts val="100"/>
-                        </a:spcAft>
-                        <a:defRPr sz="850" b="1">
+              <a:tr h="390698">
+                <a:tc>
+                  <a:txBody>
+                    <a:bodyPr/>
+                    <a:lstStyle/>
+                    <a:p>
+                      <a:pPr>
+                        <a:spcAft>
+                          <a:spcPts val="100"/>
+                        </a:spcAft>
+                        <a:defRPr sz="800" b="1">
                           <a:solidFill>
                             <a:srgbClr val="0A2373"/>
                           </a:solidFill>
@@ -14363,7 +14363,7 @@
                         <a:spcAft>
                           <a:spcPts val="100"/>
                         </a:spcAft>
-                        <a:defRPr sz="850" b="0">
+                        <a:defRPr sz="800" b="0">
                           <a:solidFill>
                             <a:srgbClr val="11151A"/>
                           </a:solidFill>
@@ -14404,7 +14404,7 @@
                         <a:spcAft>
                           <a:spcPts val="100"/>
                         </a:spcAft>
-                        <a:defRPr sz="850" b="0">
+                        <a:defRPr sz="800" b="0">
                           <a:solidFill>
                             <a:srgbClr val="11151A"/>
                           </a:solidFill>
@@ -14413,6 +14413,131 @@
                       </a:pPr>
                       <a:r>
                         <a:t>Unchanged</a:t>
+                      </a:r>
+                    </a:p>
+                  </a:txBody>
+                  <a:tcPr marL="64008" marR="64008" marT="54864" marB="27432" anchor="t">
+                    <a:lnL w="0">
+                      <a:noFill/>
+                    </a:lnL>
+                    <a:lnR w="0">
+                      <a:noFill/>
+                    </a:lnR>
+                    <a:lnT w="0">
+                      <a:noFill/>
+                    </a:lnT>
+                    <a:lnB w="5080">
+                      <a:solidFill>
+                        <a:srgbClr val="B8B8B8"/>
+                      </a:solidFill>
+                    </a:lnB>
+                    <a:solidFill>
+                      <a:srgbClr val="FFFFFF"/>
+                    </a:solidFill>
+                  </a:tcPr>
+                </a:tc>
+              </a:tr>
+              <a:tr h="390700">
+                <a:tc>
+                  <a:txBody>
+                    <a:bodyPr/>
+                    <a:lstStyle/>
+                    <a:p>
+                      <a:pPr>
+                        <a:spcAft>
+                          <a:spcPts val="100"/>
+                        </a:spcAft>
+                        <a:defRPr sz="800" b="1">
+                          <a:solidFill>
+                            <a:srgbClr val="0A2373"/>
+                          </a:solidFill>
+                          <a:latin typeface="Lato"/>
+                        </a:defRPr>
+                      </a:pPr>
+                      <a:r>
+                        <a:t>D22  Power fleet: the three cases and the assumptions behind them</a:t>
+                      </a:r>
+                    </a:p>
+                  </a:txBody>
+                  <a:tcPr marL="64008" marR="64008" marT="54864" marB="27432" anchor="t">
+                    <a:lnL w="0">
+                      <a:noFill/>
+                    </a:lnL>
+                    <a:lnR w="0">
+                      <a:noFill/>
+                    </a:lnR>
+                    <a:lnT w="0">
+                      <a:noFill/>
+                    </a:lnT>
+                    <a:lnB w="5080">
+                      <a:solidFill>
+                        <a:srgbClr val="B8B8B8"/>
+                      </a:solidFill>
+                    </a:lnB>
+                    <a:solidFill>
+                      <a:srgbClr val="FFFFFF"/>
+                    </a:solidFill>
+                  </a:tcPr>
+                </a:tc>
+                <a:tc>
+                  <a:txBody>
+                    <a:bodyPr/>
+                    <a:lstStyle/>
+                    <a:p>
+                      <a:pPr>
+                        <a:spcAft>
+                          <a:spcPts val="100"/>
+                        </a:spcAft>
+                        <a:defRPr sz="800" b="0">
+                          <a:solidFill>
+                            <a:srgbClr val="11151A"/>
+                          </a:solidFill>
+                          <a:latin typeface="Lato"/>
+                        </a:defRPr>
+                      </a:pPr>
+                      <a:r>
+                        <a:t>Fleet defined: Ankerlig Gourikwa Avon Dedisa (3,089 MW). Low / medium / high give 20 / 637 / 4,224 million litres from 2031. Unsourced: 10% of output on diesel when gas is available; 40% load factor on gas; 0.31 litres per kWh; Avon and Dedisa continuing after 2030-2031; 6 GW of gas turbines sited at Camden Grootvlei Hendrina Arnot and Kriel; no gas reaching them in the high case</a:t>
+                      </a:r>
+                    </a:p>
+                  </a:txBody>
+                  <a:tcPr marL="64008" marR="64008" marT="54864" marB="27432" anchor="t">
+                    <a:lnL w="0">
+                      <a:noFill/>
+                    </a:lnL>
+                    <a:lnR w="0">
+                      <a:noFill/>
+                    </a:lnR>
+                    <a:lnT w="0">
+                      <a:noFill/>
+                    </a:lnT>
+                    <a:lnB w="5080">
+                      <a:solidFill>
+                        <a:srgbClr val="B8B8B8"/>
+                      </a:solidFill>
+                    </a:lnB>
+                    <a:solidFill>
+                      <a:srgbClr val="FFFFFF"/>
+                    </a:solidFill>
+                  </a:tcPr>
+                </a:tc>
+                <a:tc>
+                  <a:txBody>
+                    <a:bodyPr/>
+                    <a:lstStyle/>
+                    <a:p>
+                      <a:pPr>
+                        <a:spcAft>
+                          <a:spcPts val="100"/>
+                        </a:spcAft>
+                        <a:defRPr sz="800" b="0">
+                          <a:solidFill>
+                            <a:srgbClr val="11151A"/>
+                          </a:solidFill>
+                          <a:latin typeface="Lato"/>
+                        </a:defRPr>
+                      </a:pPr>
+                      <a:r>
+                        <a:t>Accept the fleet; confirm or change each case setting; replaces the two placeholder stations in the model</a:t>
                       </a:r>
                     </a:p>
                   </a:txBody>

</xml_diff>